<commit_message>
#178 - Launch Year Module
</commit_message>
<xml_diff>
--- a/wiki/images/Wiki Figures.pptx
+++ b/wiki/images/Wiki Figures.pptx
@@ -112,12 +112,41 @@
 </p:presentation>
 </file>
 
-<file path=ppt/revisionInfo.xml><?xml version="1.0" encoding="utf-8"?>
-<p1510:revInfo xmlns:a="http://schemas.openxmlformats.org/drawingml/2006/main" xmlns:r="http://schemas.openxmlformats.org/officeDocument/2006/relationships" xmlns:p1510="http://schemas.microsoft.com/office/powerpoint/2015/10/main">
-  <p1510:revLst>
-    <p1510:client id="{B1A37C4D-3840-44C7-8D64-5517C783AA17}" v="1" dt="2023-12-18T17:39:13.574"/>
-  </p1510:revLst>
-</p1510:revInfo>
+<file path=ppt/changesInfos/changesInfo1.xml><?xml version="1.0" encoding="utf-8"?>
+<pc:chgInfo xmlns:a="http://schemas.openxmlformats.org/drawingml/2006/main" xmlns:r="http://schemas.openxmlformats.org/officeDocument/2006/relationships" xmlns:ac="http://schemas.microsoft.com/office/drawing/2013/main/command" xmlns:pc="http://schemas.microsoft.com/office/powerpoint/2013/main/command">
+  <pc:docChgLst>
+    <pc:chgData name="Gregor Schroeder" userId="b5dc7317-29c0-420d-a3e1-6a07614f8ec9" providerId="ADAL" clId="{045A2BD9-4324-4B3B-AE34-A1847A3B2362}"/>
+    <pc:docChg chg="modSld">
+      <pc:chgData name="Gregor Schroeder" userId="b5dc7317-29c0-420d-a3e1-6a07614f8ec9" providerId="ADAL" clId="{045A2BD9-4324-4B3B-AE34-A1847A3B2362}" dt="2026-09-17T16:17:27.517" v="26" actId="20577"/>
+      <pc:docMkLst>
+        <pc:docMk/>
+      </pc:docMkLst>
+      <pc:sldChg chg="modSp mod">
+        <pc:chgData name="Gregor Schroeder" userId="b5dc7317-29c0-420d-a3e1-6a07614f8ec9" providerId="ADAL" clId="{045A2BD9-4324-4B3B-AE34-A1847A3B2362}" dt="2026-09-17T16:17:27.517" v="26" actId="20577"/>
+        <pc:sldMkLst>
+          <pc:docMk/>
+          <pc:sldMk cId="3671389095" sldId="256"/>
+        </pc:sldMkLst>
+        <pc:spChg chg="mod">
+          <ac:chgData name="Gregor Schroeder" userId="b5dc7317-29c0-420d-a3e1-6a07614f8ec9" providerId="ADAL" clId="{045A2BD9-4324-4B3B-AE34-A1847A3B2362}" dt="2026-09-17T16:17:19.884" v="6" actId="20577"/>
+          <ac:spMkLst>
+            <pc:docMk/>
+            <pc:sldMk cId="3671389095" sldId="256"/>
+            <ac:spMk id="4" creationId="{8AE186A6-FC0D-12DB-4C7B-AF82A6BD0FD9}"/>
+          </ac:spMkLst>
+        </pc:spChg>
+        <pc:spChg chg="mod">
+          <ac:chgData name="Gregor Schroeder" userId="b5dc7317-29c0-420d-a3e1-6a07614f8ec9" providerId="ADAL" clId="{045A2BD9-4324-4B3B-AE34-A1847A3B2362}" dt="2026-09-17T16:17:27.517" v="26" actId="20577"/>
+          <ac:spMkLst>
+            <pc:docMk/>
+            <pc:sldMk cId="3671389095" sldId="256"/>
+            <ac:spMk id="82" creationId="{CBCF8921-64B6-A577-76D1-2E9BE28715D5}"/>
+          </ac:spMkLst>
+        </pc:spChg>
+      </pc:sldChg>
+    </pc:docChg>
+  </pc:docChgLst>
+</pc:chgInfo>
 </file>
 
 <file path=ppt/slideLayouts/slideLayout1.xml><?xml version="1.0" encoding="utf-8"?>
@@ -267,7 +296,7 @@
           <a:p>
             <a:fld id="{178E86BF-7F65-43CF-AE46-EFD7C683430B}" type="datetimeFigureOut">
               <a:rPr lang="en-US" smtClean="0"/>
-              <a:t>12/18/2023</a:t>
+              <a:t>9/17/2026</a:t>
             </a:fld>
             <a:endParaRPr lang="en-US"/>
           </a:p>
@@ -465,7 +494,7 @@
           <a:p>
             <a:fld id="{178E86BF-7F65-43CF-AE46-EFD7C683430B}" type="datetimeFigureOut">
               <a:rPr lang="en-US" smtClean="0"/>
-              <a:t>12/18/2023</a:t>
+              <a:t>9/17/2026</a:t>
             </a:fld>
             <a:endParaRPr lang="en-US"/>
           </a:p>
@@ -673,7 +702,7 @@
           <a:p>
             <a:fld id="{178E86BF-7F65-43CF-AE46-EFD7C683430B}" type="datetimeFigureOut">
               <a:rPr lang="en-US" smtClean="0"/>
-              <a:t>12/18/2023</a:t>
+              <a:t>9/17/2026</a:t>
             </a:fld>
             <a:endParaRPr lang="en-US"/>
           </a:p>
@@ -871,7 +900,7 @@
           <a:p>
             <a:fld id="{178E86BF-7F65-43CF-AE46-EFD7C683430B}" type="datetimeFigureOut">
               <a:rPr lang="en-US" smtClean="0"/>
-              <a:t>12/18/2023</a:t>
+              <a:t>9/17/2026</a:t>
             </a:fld>
             <a:endParaRPr lang="en-US"/>
           </a:p>
@@ -1146,7 +1175,7 @@
           <a:p>
             <a:fld id="{178E86BF-7F65-43CF-AE46-EFD7C683430B}" type="datetimeFigureOut">
               <a:rPr lang="en-US" smtClean="0"/>
-              <a:t>12/18/2023</a:t>
+              <a:t>9/17/2026</a:t>
             </a:fld>
             <a:endParaRPr lang="en-US"/>
           </a:p>
@@ -1411,7 +1440,7 @@
           <a:p>
             <a:fld id="{178E86BF-7F65-43CF-AE46-EFD7C683430B}" type="datetimeFigureOut">
               <a:rPr lang="en-US" smtClean="0"/>
-              <a:t>12/18/2023</a:t>
+              <a:t>9/17/2026</a:t>
             </a:fld>
             <a:endParaRPr lang="en-US"/>
           </a:p>
@@ -1823,7 +1852,7 @@
           <a:p>
             <a:fld id="{178E86BF-7F65-43CF-AE46-EFD7C683430B}" type="datetimeFigureOut">
               <a:rPr lang="en-US" smtClean="0"/>
-              <a:t>12/18/2023</a:t>
+              <a:t>9/17/2026</a:t>
             </a:fld>
             <a:endParaRPr lang="en-US"/>
           </a:p>
@@ -1964,7 +1993,7 @@
           <a:p>
             <a:fld id="{178E86BF-7F65-43CF-AE46-EFD7C683430B}" type="datetimeFigureOut">
               <a:rPr lang="en-US" smtClean="0"/>
-              <a:t>12/18/2023</a:t>
+              <a:t>9/17/2026</a:t>
             </a:fld>
             <a:endParaRPr lang="en-US"/>
           </a:p>
@@ -2077,7 +2106,7 @@
           <a:p>
             <a:fld id="{178E86BF-7F65-43CF-AE46-EFD7C683430B}" type="datetimeFigureOut">
               <a:rPr lang="en-US" smtClean="0"/>
-              <a:t>12/18/2023</a:t>
+              <a:t>9/17/2026</a:t>
             </a:fld>
             <a:endParaRPr lang="en-US"/>
           </a:p>
@@ -2388,7 +2417,7 @@
           <a:p>
             <a:fld id="{178E86BF-7F65-43CF-AE46-EFD7C683430B}" type="datetimeFigureOut">
               <a:rPr lang="en-US" smtClean="0"/>
-              <a:t>12/18/2023</a:t>
+              <a:t>9/17/2026</a:t>
             </a:fld>
             <a:endParaRPr lang="en-US"/>
           </a:p>
@@ -2676,7 +2705,7 @@
           <a:p>
             <a:fld id="{178E86BF-7F65-43CF-AE46-EFD7C683430B}" type="datetimeFigureOut">
               <a:rPr lang="en-US" smtClean="0"/>
-              <a:t>12/18/2023</a:t>
+              <a:t>9/17/2026</a:t>
             </a:fld>
             <a:endParaRPr lang="en-US"/>
           </a:p>
@@ -2917,7 +2946,7 @@
           <a:p>
             <a:fld id="{178E86BF-7F65-43CF-AE46-EFD7C683430B}" type="datetimeFigureOut">
               <a:rPr lang="en-US" smtClean="0"/>
-              <a:t>12/18/2023</a:t>
+              <a:t>9/17/2026</a:t>
             </a:fld>
             <a:endParaRPr lang="en-US"/>
           </a:p>
@@ -3385,7 +3414,7 @@
                   <a:schemeClr val="tx1"/>
                 </a:solidFill>
               </a:rPr>
-              <a:t>Base Year Population (2010/2020)</a:t>
+              <a:t>Launch Year Population</a:t>
             </a:r>
           </a:p>
         </p:txBody>
@@ -5321,8 +5350,8 @@
         </p:nvSpPr>
         <p:spPr>
           <a:xfrm>
-            <a:off x="166360" y="2562889"/>
-            <a:ext cx="2160656" cy="523220"/>
+            <a:off x="415883" y="2562889"/>
+            <a:ext cx="1661609" cy="523220"/>
           </a:xfrm>
           <a:prstGeom prst="rect">
             <a:avLst/>
@@ -5345,7 +5374,7 @@
             </a:br>
             <a:r>
               <a:rPr lang="en-US" sz="1400" dirty="0"/>
-              <a:t>Base Year &lt;= Launch Year</a:t>
+              <a:t>SANDAG Estimates</a:t>
             </a:r>
           </a:p>
         </p:txBody>

</xml_diff>

<commit_message>
#183 - PR Feedback (misspellings/typos)
</commit_message>
<xml_diff>
--- a/wiki/images/Wiki Figures.pptx
+++ b/wiki/images/Wiki Figures.pptx
@@ -116,13 +116,13 @@
 <pc:chgInfo xmlns:a="http://schemas.openxmlformats.org/drawingml/2006/main" xmlns:r="http://schemas.openxmlformats.org/officeDocument/2006/relationships" xmlns:ac="http://schemas.microsoft.com/office/drawing/2013/main/command" xmlns:pc="http://schemas.microsoft.com/office/powerpoint/2013/main/command">
   <pc:docChgLst>
     <pc:chgData name="Gregor Schroeder" userId="b5dc7317-29c0-420d-a3e1-6a07614f8ec9" providerId="ADAL" clId="{045A2BD9-4324-4B3B-AE34-A1847A3B2362}"/>
-    <pc:docChg chg="modSld">
-      <pc:chgData name="Gregor Schroeder" userId="b5dc7317-29c0-420d-a3e1-6a07614f8ec9" providerId="ADAL" clId="{045A2BD9-4324-4B3B-AE34-A1847A3B2362}" dt="2026-09-17T16:17:27.517" v="26" actId="20577"/>
+    <pc:docChg chg="undo custSel modSld">
+      <pc:chgData name="Gregor Schroeder" userId="b5dc7317-29c0-420d-a3e1-6a07614f8ec9" providerId="ADAL" clId="{045A2BD9-4324-4B3B-AE34-A1847A3B2362}" dt="2026-09-29T18:36:26.231" v="100" actId="14100"/>
       <pc:docMkLst>
         <pc:docMk/>
       </pc:docMkLst>
       <pc:sldChg chg="modSp mod">
-        <pc:chgData name="Gregor Schroeder" userId="b5dc7317-29c0-420d-a3e1-6a07614f8ec9" providerId="ADAL" clId="{045A2BD9-4324-4B3B-AE34-A1847A3B2362}" dt="2026-09-17T16:17:27.517" v="26" actId="20577"/>
+        <pc:chgData name="Gregor Schroeder" userId="b5dc7317-29c0-420d-a3e1-6a07614f8ec9" providerId="ADAL" clId="{045A2BD9-4324-4B3B-AE34-A1847A3B2362}" dt="2026-09-29T18:36:26.231" v="100" actId="14100"/>
         <pc:sldMkLst>
           <pc:docMk/>
           <pc:sldMk cId="3671389095" sldId="256"/>
@@ -136,6 +136,62 @@
           </ac:spMkLst>
         </pc:spChg>
         <pc:spChg chg="mod">
+          <ac:chgData name="Gregor Schroeder" userId="b5dc7317-29c0-420d-a3e1-6a07614f8ec9" providerId="ADAL" clId="{045A2BD9-4324-4B3B-AE34-A1847A3B2362}" dt="2026-09-29T17:02:29.499" v="55" actId="14100"/>
+          <ac:spMkLst>
+            <pc:docMk/>
+            <pc:sldMk cId="3671389095" sldId="256"/>
+            <ac:spMk id="9" creationId="{0AE9DE5E-1ACA-0E72-81FF-6C27771DE4C8}"/>
+          </ac:spMkLst>
+        </pc:spChg>
+        <pc:spChg chg="mod">
+          <ac:chgData name="Gregor Schroeder" userId="b5dc7317-29c0-420d-a3e1-6a07614f8ec9" providerId="ADAL" clId="{045A2BD9-4324-4B3B-AE34-A1847A3B2362}" dt="2026-09-29T17:02:21.315" v="53" actId="14100"/>
+          <ac:spMkLst>
+            <pc:docMk/>
+            <pc:sldMk cId="3671389095" sldId="256"/>
+            <ac:spMk id="10" creationId="{7EA4AD1F-092F-7D64-3E2C-0677B11A0EBC}"/>
+          </ac:spMkLst>
+        </pc:spChg>
+        <pc:spChg chg="mod">
+          <ac:chgData name="Gregor Schroeder" userId="b5dc7317-29c0-420d-a3e1-6a07614f8ec9" providerId="ADAL" clId="{045A2BD9-4324-4B3B-AE34-A1847A3B2362}" dt="2026-09-29T18:36:26.231" v="100" actId="14100"/>
+          <ac:spMkLst>
+            <pc:docMk/>
+            <pc:sldMk cId="3671389095" sldId="256"/>
+            <ac:spMk id="34" creationId="{EF788281-F223-CCF5-BEFE-9812E27C77AF}"/>
+          </ac:spMkLst>
+        </pc:spChg>
+        <pc:spChg chg="mod">
+          <ac:chgData name="Gregor Schroeder" userId="b5dc7317-29c0-420d-a3e1-6a07614f8ec9" providerId="ADAL" clId="{045A2BD9-4324-4B3B-AE34-A1847A3B2362}" dt="2026-09-29T17:03:32.556" v="76" actId="14100"/>
+          <ac:spMkLst>
+            <pc:docMk/>
+            <pc:sldMk cId="3671389095" sldId="256"/>
+            <ac:spMk id="45" creationId="{6007FB49-A7C6-A588-183F-8104F2CA36A7}"/>
+          </ac:spMkLst>
+        </pc:spChg>
+        <pc:spChg chg="mod">
+          <ac:chgData name="Gregor Schroeder" userId="b5dc7317-29c0-420d-a3e1-6a07614f8ec9" providerId="ADAL" clId="{045A2BD9-4324-4B3B-AE34-A1847A3B2362}" dt="2026-09-29T17:03:14.431" v="72" actId="20577"/>
+          <ac:spMkLst>
+            <pc:docMk/>
+            <pc:sldMk cId="3671389095" sldId="256"/>
+            <ac:spMk id="46" creationId="{F876CC98-48FC-1C80-A142-FA990FCE9B69}"/>
+          </ac:spMkLst>
+        </pc:spChg>
+        <pc:spChg chg="mod">
+          <ac:chgData name="Gregor Schroeder" userId="b5dc7317-29c0-420d-a3e1-6a07614f8ec9" providerId="ADAL" clId="{045A2BD9-4324-4B3B-AE34-A1847A3B2362}" dt="2026-09-29T17:04:54.796" v="94" actId="14100"/>
+          <ac:spMkLst>
+            <pc:docMk/>
+            <pc:sldMk cId="3671389095" sldId="256"/>
+            <ac:spMk id="60" creationId="{F5526867-F547-1982-3A88-8D3D87B797DA}"/>
+          </ac:spMkLst>
+        </pc:spChg>
+        <pc:spChg chg="mod">
+          <ac:chgData name="Gregor Schroeder" userId="b5dc7317-29c0-420d-a3e1-6a07614f8ec9" providerId="ADAL" clId="{045A2BD9-4324-4B3B-AE34-A1847A3B2362}" dt="2026-09-29T17:04:58.549" v="95" actId="20577"/>
+          <ac:spMkLst>
+            <pc:docMk/>
+            <pc:sldMk cId="3671389095" sldId="256"/>
+            <ac:spMk id="61" creationId="{1F737E41-3DDC-14D3-6B9C-412C265A7C6E}"/>
+          </ac:spMkLst>
+        </pc:spChg>
+        <pc:spChg chg="mod">
           <ac:chgData name="Gregor Schroeder" userId="b5dc7317-29c0-420d-a3e1-6a07614f8ec9" providerId="ADAL" clId="{045A2BD9-4324-4B3B-AE34-A1847A3B2362}" dt="2026-09-17T16:17:27.517" v="26" actId="20577"/>
           <ac:spMkLst>
             <pc:docMk/>
@@ -143,6 +199,30 @@
             <ac:spMk id="82" creationId="{CBCF8921-64B6-A577-76D1-2E9BE28715D5}"/>
           </ac:spMkLst>
         </pc:spChg>
+        <pc:cxnChg chg="mod">
+          <ac:chgData name="Gregor Schroeder" userId="b5dc7317-29c0-420d-a3e1-6a07614f8ec9" providerId="ADAL" clId="{045A2BD9-4324-4B3B-AE34-A1847A3B2362}" dt="2026-09-29T17:02:29.499" v="55" actId="14100"/>
+          <ac:cxnSpMkLst>
+            <pc:docMk/>
+            <pc:sldMk cId="3671389095" sldId="256"/>
+            <ac:cxnSpMk id="12" creationId="{26CD92FA-81A6-CD93-8438-34C97DD5A348}"/>
+          </ac:cxnSpMkLst>
+        </pc:cxnChg>
+        <pc:cxnChg chg="mod">
+          <ac:chgData name="Gregor Schroeder" userId="b5dc7317-29c0-420d-a3e1-6a07614f8ec9" providerId="ADAL" clId="{045A2BD9-4324-4B3B-AE34-A1847A3B2362}" dt="2026-09-29T17:02:29.499" v="55" actId="14100"/>
+          <ac:cxnSpMkLst>
+            <pc:docMk/>
+            <pc:sldMk cId="3671389095" sldId="256"/>
+            <ac:cxnSpMk id="13" creationId="{08DBA490-DA57-9602-65F0-076438C61A53}"/>
+          </ac:cxnSpMkLst>
+        </pc:cxnChg>
+        <pc:cxnChg chg="mod">
+          <ac:chgData name="Gregor Schroeder" userId="b5dc7317-29c0-420d-a3e1-6a07614f8ec9" providerId="ADAL" clId="{045A2BD9-4324-4B3B-AE34-A1847A3B2362}" dt="2026-09-29T17:03:14.431" v="72" actId="20577"/>
+          <ac:cxnSpMkLst>
+            <pc:docMk/>
+            <pc:sldMk cId="3671389095" sldId="256"/>
+            <ac:cxnSpMk id="51" creationId="{3FA2AB39-617C-E4D8-799F-1F185785015E}"/>
+          </ac:cxnSpMkLst>
+        </pc:cxnChg>
       </pc:sldChg>
     </pc:docChg>
   </pc:docChgLst>
@@ -296,7 +376,7 @@
           <a:p>
             <a:fld id="{178E86BF-7F65-43CF-AE46-EFD7C683430B}" type="datetimeFigureOut">
               <a:rPr lang="en-US" smtClean="0"/>
-              <a:t>9/17/2026</a:t>
+              <a:t>9/29/2026</a:t>
             </a:fld>
             <a:endParaRPr lang="en-US"/>
           </a:p>
@@ -494,7 +574,7 @@
           <a:p>
             <a:fld id="{178E86BF-7F65-43CF-AE46-EFD7C683430B}" type="datetimeFigureOut">
               <a:rPr lang="en-US" smtClean="0"/>
-              <a:t>9/17/2026</a:t>
+              <a:t>9/29/2026</a:t>
             </a:fld>
             <a:endParaRPr lang="en-US"/>
           </a:p>
@@ -702,7 +782,7 @@
           <a:p>
             <a:fld id="{178E86BF-7F65-43CF-AE46-EFD7C683430B}" type="datetimeFigureOut">
               <a:rPr lang="en-US" smtClean="0"/>
-              <a:t>9/17/2026</a:t>
+              <a:t>9/29/2026</a:t>
             </a:fld>
             <a:endParaRPr lang="en-US"/>
           </a:p>
@@ -900,7 +980,7 @@
           <a:p>
             <a:fld id="{178E86BF-7F65-43CF-AE46-EFD7C683430B}" type="datetimeFigureOut">
               <a:rPr lang="en-US" smtClean="0"/>
-              <a:t>9/17/2026</a:t>
+              <a:t>9/29/2026</a:t>
             </a:fld>
             <a:endParaRPr lang="en-US"/>
           </a:p>
@@ -1175,7 +1255,7 @@
           <a:p>
             <a:fld id="{178E86BF-7F65-43CF-AE46-EFD7C683430B}" type="datetimeFigureOut">
               <a:rPr lang="en-US" smtClean="0"/>
-              <a:t>9/17/2026</a:t>
+              <a:t>9/29/2026</a:t>
             </a:fld>
             <a:endParaRPr lang="en-US"/>
           </a:p>
@@ -1440,7 +1520,7 @@
           <a:p>
             <a:fld id="{178E86BF-7F65-43CF-AE46-EFD7C683430B}" type="datetimeFigureOut">
               <a:rPr lang="en-US" smtClean="0"/>
-              <a:t>9/17/2026</a:t>
+              <a:t>9/29/2026</a:t>
             </a:fld>
             <a:endParaRPr lang="en-US"/>
           </a:p>
@@ -1852,7 +1932,7 @@
           <a:p>
             <a:fld id="{178E86BF-7F65-43CF-AE46-EFD7C683430B}" type="datetimeFigureOut">
               <a:rPr lang="en-US" smtClean="0"/>
-              <a:t>9/17/2026</a:t>
+              <a:t>9/29/2026</a:t>
             </a:fld>
             <a:endParaRPr lang="en-US"/>
           </a:p>
@@ -1993,7 +2073,7 @@
           <a:p>
             <a:fld id="{178E86BF-7F65-43CF-AE46-EFD7C683430B}" type="datetimeFigureOut">
               <a:rPr lang="en-US" smtClean="0"/>
-              <a:t>9/17/2026</a:t>
+              <a:t>9/29/2026</a:t>
             </a:fld>
             <a:endParaRPr lang="en-US"/>
           </a:p>
@@ -2106,7 +2186,7 @@
           <a:p>
             <a:fld id="{178E86BF-7F65-43CF-AE46-EFD7C683430B}" type="datetimeFigureOut">
               <a:rPr lang="en-US" smtClean="0"/>
-              <a:t>9/17/2026</a:t>
+              <a:t>9/29/2026</a:t>
             </a:fld>
             <a:endParaRPr lang="en-US"/>
           </a:p>
@@ -2417,7 +2497,7 @@
           <a:p>
             <a:fld id="{178E86BF-7F65-43CF-AE46-EFD7C683430B}" type="datetimeFigureOut">
               <a:rPr lang="en-US" smtClean="0"/>
-              <a:t>9/17/2026</a:t>
+              <a:t>9/29/2026</a:t>
             </a:fld>
             <a:endParaRPr lang="en-US"/>
           </a:p>
@@ -2705,7 +2785,7 @@
           <a:p>
             <a:fld id="{178E86BF-7F65-43CF-AE46-EFD7C683430B}" type="datetimeFigureOut">
               <a:rPr lang="en-US" smtClean="0"/>
-              <a:t>9/17/2026</a:t>
+              <a:t>9/29/2026</a:t>
             </a:fld>
             <a:endParaRPr lang="en-US"/>
           </a:p>
@@ -2946,7 +3026,7 @@
           <a:p>
             <a:fld id="{178E86BF-7F65-43CF-AE46-EFD7C683430B}" type="datetimeFigureOut">
               <a:rPr lang="en-US" smtClean="0"/>
-              <a:t>9/17/2026</a:t>
+              <a:t>9/29/2026</a:t>
             </a:fld>
             <a:endParaRPr lang="en-US"/>
           </a:p>
@@ -3480,8 +3560,8 @@
         </p:nvSpPr>
         <p:spPr>
           <a:xfrm>
-            <a:off x="3764281" y="1358481"/>
-            <a:ext cx="1062892" cy="500503"/>
+            <a:off x="3660928" y="1358481"/>
+            <a:ext cx="1289579" cy="500503"/>
           </a:xfrm>
           <a:prstGeom prst="rect">
             <a:avLst/>
@@ -3527,8 +3607,8 @@
         </p:nvSpPr>
         <p:spPr>
           <a:xfrm>
-            <a:off x="3745769" y="1358482"/>
-            <a:ext cx="1099916" cy="461665"/>
+            <a:off x="3622432" y="1358482"/>
+            <a:ext cx="1346587" cy="461665"/>
           </a:xfrm>
           <a:prstGeom prst="rect">
             <a:avLst/>
@@ -3536,7 +3616,7 @@
           <a:noFill/>
         </p:spPr>
         <p:txBody>
-          <a:bodyPr wrap="none" rtlCol="0">
+          <a:bodyPr wrap="square" rtlCol="0">
             <a:spAutoFit/>
           </a:bodyPr>
           <a:lstStyle/>
@@ -3563,7 +3643,7 @@
                   <a:srgbClr val="FFFF00"/>
                 </a:highlight>
               </a:rPr>
-              <a:t>Race/Sex/Age</a:t>
+              <a:t>Age/Sex/Ethnicity</a:t>
             </a:r>
           </a:p>
         </p:txBody>
@@ -3586,7 +3666,7 @@
         <p:spPr>
           <a:xfrm flipH="1">
             <a:off x="3623603" y="1858984"/>
-            <a:ext cx="672124" cy="625912"/>
+            <a:ext cx="682115" cy="625912"/>
           </a:xfrm>
           <a:prstGeom prst="straightConnector1">
             <a:avLst/>
@@ -3627,8 +3707,8 @@
         </p:nvCxnSpPr>
         <p:spPr>
           <a:xfrm>
-            <a:off x="4295727" y="1858984"/>
-            <a:ext cx="773723" cy="606811"/>
+            <a:off x="4305718" y="1858984"/>
+            <a:ext cx="763732" cy="606811"/>
           </a:xfrm>
           <a:prstGeom prst="straightConnector1">
             <a:avLst/>
@@ -4075,8 +4155,8 @@
         </p:nvSpPr>
         <p:spPr>
           <a:xfrm>
-            <a:off x="2721177" y="3515648"/>
-            <a:ext cx="1036212" cy="646331"/>
+            <a:off x="2640036" y="3515648"/>
+            <a:ext cx="1209573" cy="646331"/>
           </a:xfrm>
           <a:prstGeom prst="rect">
             <a:avLst/>
@@ -4099,7 +4179,7 @@
             </a:br>
             <a:r>
               <a:rPr lang="en-US" sz="1200" dirty="0"/>
-              <a:t>Characterics</a:t>
+              <a:t>Characteristics</a:t>
             </a:r>
             <a:br>
               <a:rPr lang="en-US" sz="1200" dirty="0"/>
@@ -4353,8 +4433,8 @@
         </p:nvSpPr>
         <p:spPr>
           <a:xfrm>
-            <a:off x="8807935" y="1336310"/>
-            <a:ext cx="1062892" cy="500503"/>
+            <a:off x="8714986" y="1336310"/>
+            <a:ext cx="1290931" cy="500503"/>
           </a:xfrm>
           <a:prstGeom prst="rect">
             <a:avLst/>
@@ -4382,7 +4462,7 @@
           <a:lstStyle/>
           <a:p>
             <a:pPr algn="ctr"/>
-            <a:endParaRPr lang="en-US"/>
+            <a:endParaRPr lang="en-US" dirty="0"/>
           </a:p>
         </p:txBody>
       </p:sp>
@@ -4400,8 +4480,8 @@
         </p:nvSpPr>
         <p:spPr>
           <a:xfrm>
-            <a:off x="8789423" y="1336311"/>
-            <a:ext cx="1099916" cy="461665"/>
+            <a:off x="8666088" y="1336311"/>
+            <a:ext cx="1346587" cy="461665"/>
           </a:xfrm>
           <a:prstGeom prst="rect">
             <a:avLst/>
@@ -4424,7 +4504,7 @@
             </a:br>
             <a:r>
               <a:rPr lang="en-US" sz="1200" dirty="0"/>
-              <a:t>Race/Sex/Age</a:t>
+              <a:t>Age/Sex/Ethnicity</a:t>
             </a:r>
           </a:p>
         </p:txBody>
@@ -4478,6 +4558,7 @@
             </a:extLst>
           </p:cNvPr>
           <p:cNvCxnSpPr>
+            <a:cxnSpLocks/>
             <a:stCxn id="10" idx="3"/>
             <a:endCxn id="46" idx="1"/>
           </p:cNvCxnSpPr>
@@ -4485,8 +4566,8 @@
         </p:nvCxnSpPr>
         <p:spPr>
           <a:xfrm flipV="1">
-            <a:off x="4845685" y="1567144"/>
-            <a:ext cx="3943738" cy="22171"/>
+            <a:off x="4969019" y="1567144"/>
+            <a:ext cx="3697069" cy="22171"/>
           </a:xfrm>
           <a:prstGeom prst="straightConnector1">
             <a:avLst/>
@@ -4851,8 +4932,8 @@
         </p:nvSpPr>
         <p:spPr>
           <a:xfrm>
-            <a:off x="8786623" y="5152127"/>
-            <a:ext cx="1062892" cy="703455"/>
+            <a:off x="8714986" y="5152127"/>
+            <a:ext cx="1245403" cy="703455"/>
           </a:xfrm>
           <a:prstGeom prst="rect">
             <a:avLst/>
@@ -4898,8 +4979,8 @@
         </p:nvSpPr>
         <p:spPr>
           <a:xfrm>
-            <a:off x="8714987" y="5189571"/>
-            <a:ext cx="1206164" cy="646331"/>
+            <a:off x="8644777" y="5189571"/>
+            <a:ext cx="1346587" cy="646331"/>
           </a:xfrm>
           <a:prstGeom prst="rect">
             <a:avLst/>
@@ -4949,7 +5030,7 @@
                   <a:srgbClr val="FFFF00"/>
                 </a:highlight>
               </a:rPr>
-              <a:t>Race/Sex/Age</a:t>
+              <a:t>Age/Sex/Ethnicity</a:t>
             </a:r>
           </a:p>
         </p:txBody>

</xml_diff>

<commit_message>
#206 - Housing module
</commit_message>
<xml_diff>
--- a/wiki/images/Wiki Figures.pptx
+++ b/wiki/images/Wiki Figures.pptx
@@ -112,27 +112,43 @@
 </p:presentation>
 </file>
 
+<file path=ppt/revisionInfo.xml><?xml version="1.0" encoding="utf-8"?>
+<p1510:revInfo xmlns:a="http://schemas.openxmlformats.org/drawingml/2006/main" xmlns:r="http://schemas.openxmlformats.org/officeDocument/2006/relationships" xmlns:p1510="http://schemas.microsoft.com/office/powerpoint/2015/10/main">
+  <p1510:revLst>
+    <p1510:client id="{7F2D61F6-C19A-4B51-BED3-E77326EFC41B}" v="2" dt="2026-10-21T00:27:42.993"/>
+  </p1510:revLst>
+</p1510:revInfo>
+</file>
+
 <file path=ppt/changesInfos/changesInfo1.xml><?xml version="1.0" encoding="utf-8"?>
 <pc:chgInfo xmlns:a="http://schemas.openxmlformats.org/drawingml/2006/main" xmlns:r="http://schemas.openxmlformats.org/officeDocument/2006/relationships" xmlns:ac="http://schemas.microsoft.com/office/drawing/2013/main/command" xmlns:pc="http://schemas.microsoft.com/office/powerpoint/2013/main/command">
   <pc:docChgLst>
     <pc:chgData name="Gregor Schroeder" userId="b5dc7317-29c0-420d-a3e1-6a07614f8ec9" providerId="ADAL" clId="{045A2BD9-4324-4B3B-AE34-A1847A3B2362}"/>
-    <pc:docChg chg="undo custSel modSld">
-      <pc:chgData name="Gregor Schroeder" userId="b5dc7317-29c0-420d-a3e1-6a07614f8ec9" providerId="ADAL" clId="{045A2BD9-4324-4B3B-AE34-A1847A3B2362}" dt="2026-09-29T18:36:26.231" v="100" actId="14100"/>
+    <pc:docChg chg="undo redo custSel modSld">
+      <pc:chgData name="Gregor Schroeder" userId="b5dc7317-29c0-420d-a3e1-6a07614f8ec9" providerId="ADAL" clId="{045A2BD9-4324-4B3B-AE34-A1847A3B2362}" dt="2026-10-21T00:31:43.814" v="245" actId="1076"/>
       <pc:docMkLst>
         <pc:docMk/>
       </pc:docMkLst>
-      <pc:sldChg chg="modSp mod">
-        <pc:chgData name="Gregor Schroeder" userId="b5dc7317-29c0-420d-a3e1-6a07614f8ec9" providerId="ADAL" clId="{045A2BD9-4324-4B3B-AE34-A1847A3B2362}" dt="2026-09-29T18:36:26.231" v="100" actId="14100"/>
+      <pc:sldChg chg="addSp delSp modSp mod">
+        <pc:chgData name="Gregor Schroeder" userId="b5dc7317-29c0-420d-a3e1-6a07614f8ec9" providerId="ADAL" clId="{045A2BD9-4324-4B3B-AE34-A1847A3B2362}" dt="2026-10-21T00:31:43.814" v="245" actId="1076"/>
         <pc:sldMkLst>
           <pc:docMk/>
           <pc:sldMk cId="3671389095" sldId="256"/>
         </pc:sldMkLst>
         <pc:spChg chg="mod">
-          <ac:chgData name="Gregor Schroeder" userId="b5dc7317-29c0-420d-a3e1-6a07614f8ec9" providerId="ADAL" clId="{045A2BD9-4324-4B3B-AE34-A1847A3B2362}" dt="2026-09-17T16:17:19.884" v="6" actId="20577"/>
+          <ac:chgData name="Gregor Schroeder" userId="b5dc7317-29c0-420d-a3e1-6a07614f8ec9" providerId="ADAL" clId="{045A2BD9-4324-4B3B-AE34-A1847A3B2362}" dt="2026-10-21T00:25:48.645" v="129" actId="1076"/>
           <ac:spMkLst>
             <pc:docMk/>
             <pc:sldMk cId="3671389095" sldId="256"/>
             <ac:spMk id="4" creationId="{8AE186A6-FC0D-12DB-4C7B-AF82A6BD0FD9}"/>
+          </ac:spMkLst>
+        </pc:spChg>
+        <pc:spChg chg="mod">
+          <ac:chgData name="Gregor Schroeder" userId="b5dc7317-29c0-420d-a3e1-6a07614f8ec9" providerId="ADAL" clId="{045A2BD9-4324-4B3B-AE34-A1847A3B2362}" dt="2026-10-21T00:25:48.645" v="129" actId="1076"/>
+          <ac:spMkLst>
+            <pc:docMk/>
+            <pc:sldMk cId="3671389095" sldId="256"/>
+            <ac:spMk id="7" creationId="{43581310-5C3E-219E-4B43-8CBB7858D68D}"/>
           </ac:spMkLst>
         </pc:spChg>
         <pc:spChg chg="mod">
@@ -152,11 +168,115 @@
           </ac:spMkLst>
         </pc:spChg>
         <pc:spChg chg="mod">
-          <ac:chgData name="Gregor Schroeder" userId="b5dc7317-29c0-420d-a3e1-6a07614f8ec9" providerId="ADAL" clId="{045A2BD9-4324-4B3B-AE34-A1847A3B2362}" dt="2026-09-29T18:36:26.231" v="100" actId="14100"/>
+          <ac:chgData name="Gregor Schroeder" userId="b5dc7317-29c0-420d-a3e1-6a07614f8ec9" providerId="ADAL" clId="{045A2BD9-4324-4B3B-AE34-A1847A3B2362}" dt="2026-10-21T00:27:00.549" v="142" actId="1076"/>
+          <ac:spMkLst>
+            <pc:docMk/>
+            <pc:sldMk cId="3671389095" sldId="256"/>
+            <ac:spMk id="17" creationId="{A603C946-9914-2716-E726-43B741173BB1}"/>
+          </ac:spMkLst>
+        </pc:spChg>
+        <pc:spChg chg="mod">
+          <ac:chgData name="Gregor Schroeder" userId="b5dc7317-29c0-420d-a3e1-6a07614f8ec9" providerId="ADAL" clId="{045A2BD9-4324-4B3B-AE34-A1847A3B2362}" dt="2026-10-21T00:27:00.549" v="142" actId="1076"/>
+          <ac:spMkLst>
+            <pc:docMk/>
+            <pc:sldMk cId="3671389095" sldId="256"/>
+            <ac:spMk id="18" creationId="{1CFA7E4D-44FC-46AA-AC23-6CDBC0ED0924}"/>
+          </ac:spMkLst>
+        </pc:spChg>
+        <pc:spChg chg="mod">
+          <ac:chgData name="Gregor Schroeder" userId="b5dc7317-29c0-420d-a3e1-6a07614f8ec9" providerId="ADAL" clId="{045A2BD9-4324-4B3B-AE34-A1847A3B2362}" dt="2026-10-21T00:29:32.354" v="233" actId="1076"/>
+          <ac:spMkLst>
+            <pc:docMk/>
+            <pc:sldMk cId="3671389095" sldId="256"/>
+            <ac:spMk id="19" creationId="{3F1D5BD2-7410-CBDC-B5FD-C3AD634E4E07}"/>
+          </ac:spMkLst>
+        </pc:spChg>
+        <pc:spChg chg="mod">
+          <ac:chgData name="Gregor Schroeder" userId="b5dc7317-29c0-420d-a3e1-6a07614f8ec9" providerId="ADAL" clId="{045A2BD9-4324-4B3B-AE34-A1847A3B2362}" dt="2026-10-21T00:29:32.354" v="233" actId="1076"/>
+          <ac:spMkLst>
+            <pc:docMk/>
+            <pc:sldMk cId="3671389095" sldId="256"/>
+            <ac:spMk id="20" creationId="{B6071384-73C8-8410-DAB8-5D0AED605679}"/>
+          </ac:spMkLst>
+        </pc:spChg>
+        <pc:spChg chg="add mod">
+          <ac:chgData name="Gregor Schroeder" userId="b5dc7317-29c0-420d-a3e1-6a07614f8ec9" providerId="ADAL" clId="{045A2BD9-4324-4B3B-AE34-A1847A3B2362}" dt="2026-10-21T00:30:55.949" v="243" actId="1076"/>
+          <ac:spMkLst>
+            <pc:docMk/>
+            <pc:sldMk cId="3671389095" sldId="256"/>
+            <ac:spMk id="27" creationId="{36ED4FAD-EDFF-2D9B-ACEA-4318FAFBA454}"/>
+          </ac:spMkLst>
+        </pc:spChg>
+        <pc:spChg chg="mod">
+          <ac:chgData name="Gregor Schroeder" userId="b5dc7317-29c0-420d-a3e1-6a07614f8ec9" providerId="ADAL" clId="{045A2BD9-4324-4B3B-AE34-A1847A3B2362}" dt="2026-10-21T00:29:32.354" v="233" actId="1076"/>
+          <ac:spMkLst>
+            <pc:docMk/>
+            <pc:sldMk cId="3671389095" sldId="256"/>
+            <ac:spMk id="30" creationId="{064BA4F6-C2CA-7201-18AF-616194CBCE86}"/>
+          </ac:spMkLst>
+        </pc:spChg>
+        <pc:spChg chg="mod">
+          <ac:chgData name="Gregor Schroeder" userId="b5dc7317-29c0-420d-a3e1-6a07614f8ec9" providerId="ADAL" clId="{045A2BD9-4324-4B3B-AE34-A1847A3B2362}" dt="2026-10-21T00:29:32.354" v="233" actId="1076"/>
+          <ac:spMkLst>
+            <pc:docMk/>
+            <pc:sldMk cId="3671389095" sldId="256"/>
+            <ac:spMk id="31" creationId="{615286B9-9985-ECA4-12BC-F7A4662DE6B4}"/>
+          </ac:spMkLst>
+        </pc:spChg>
+        <pc:spChg chg="mod">
+          <ac:chgData name="Gregor Schroeder" userId="b5dc7317-29c0-420d-a3e1-6a07614f8ec9" providerId="ADAL" clId="{045A2BD9-4324-4B3B-AE34-A1847A3B2362}" dt="2026-10-21T00:30:28.020" v="240" actId="1076"/>
+          <ac:spMkLst>
+            <pc:docMk/>
+            <pc:sldMk cId="3671389095" sldId="256"/>
+            <ac:spMk id="33" creationId="{2362F874-F5F5-5307-EF24-C4BAE949B4E2}"/>
+          </ac:spMkLst>
+        </pc:spChg>
+        <pc:spChg chg="mod">
+          <ac:chgData name="Gregor Schroeder" userId="b5dc7317-29c0-420d-a3e1-6a07614f8ec9" providerId="ADAL" clId="{045A2BD9-4324-4B3B-AE34-A1847A3B2362}" dt="2026-10-21T00:30:28.020" v="240" actId="1076"/>
           <ac:spMkLst>
             <pc:docMk/>
             <pc:sldMk cId="3671389095" sldId="256"/>
             <ac:spMk id="34" creationId="{EF788281-F223-CCF5-BEFE-9812E27C77AF}"/>
+          </ac:spMkLst>
+        </pc:spChg>
+        <pc:spChg chg="add mod">
+          <ac:chgData name="Gregor Schroeder" userId="b5dc7317-29c0-420d-a3e1-6a07614f8ec9" providerId="ADAL" clId="{045A2BD9-4324-4B3B-AE34-A1847A3B2362}" dt="2026-10-21T00:30:55.949" v="243" actId="1076"/>
+          <ac:spMkLst>
+            <pc:docMk/>
+            <pc:sldMk cId="3671389095" sldId="256"/>
+            <ac:spMk id="35" creationId="{BDAEA6C6-03B8-D62B-ACC1-ABA1FEF7D8CA}"/>
+          </ac:spMkLst>
+        </pc:spChg>
+        <pc:spChg chg="mod">
+          <ac:chgData name="Gregor Schroeder" userId="b5dc7317-29c0-420d-a3e1-6a07614f8ec9" providerId="ADAL" clId="{045A2BD9-4324-4B3B-AE34-A1847A3B2362}" dt="2026-10-21T00:30:28.020" v="240" actId="1076"/>
+          <ac:spMkLst>
+            <pc:docMk/>
+            <pc:sldMk cId="3671389095" sldId="256"/>
+            <ac:spMk id="38" creationId="{2EC7A187-731B-ABC3-8FD7-771AFE0C80DD}"/>
+          </ac:spMkLst>
+        </pc:spChg>
+        <pc:spChg chg="mod">
+          <ac:chgData name="Gregor Schroeder" userId="b5dc7317-29c0-420d-a3e1-6a07614f8ec9" providerId="ADAL" clId="{045A2BD9-4324-4B3B-AE34-A1847A3B2362}" dt="2026-10-21T00:30:28.020" v="240" actId="1076"/>
+          <ac:spMkLst>
+            <pc:docMk/>
+            <pc:sldMk cId="3671389095" sldId="256"/>
+            <ac:spMk id="39" creationId="{D7A22444-CA6D-D4DE-42E8-AD1D011F8A1B}"/>
+          </ac:spMkLst>
+        </pc:spChg>
+        <pc:spChg chg="mod">
+          <ac:chgData name="Gregor Schroeder" userId="b5dc7317-29c0-420d-a3e1-6a07614f8ec9" providerId="ADAL" clId="{045A2BD9-4324-4B3B-AE34-A1847A3B2362}" dt="2026-10-21T00:29:14.909" v="230" actId="14100"/>
+          <ac:spMkLst>
+            <pc:docMk/>
+            <pc:sldMk cId="3671389095" sldId="256"/>
+            <ac:spMk id="42" creationId="{497F0F9B-D7EF-4699-C7DC-7BDC7384E8DA}"/>
+          </ac:spMkLst>
+        </pc:spChg>
+        <pc:spChg chg="mod">
+          <ac:chgData name="Gregor Schroeder" userId="b5dc7317-29c0-420d-a3e1-6a07614f8ec9" providerId="ADAL" clId="{045A2BD9-4324-4B3B-AE34-A1847A3B2362}" dt="2026-10-21T00:31:43.814" v="245" actId="1076"/>
+          <ac:spMkLst>
+            <pc:docMk/>
+            <pc:sldMk cId="3671389095" sldId="256"/>
+            <ac:spMk id="43" creationId="{B171E405-E458-A8B0-528F-0F1F90791B85}"/>
           </ac:spMkLst>
         </pc:spChg>
         <pc:spChg chg="mod">
@@ -192,15 +312,23 @@
           </ac:spMkLst>
         </pc:spChg>
         <pc:spChg chg="mod">
-          <ac:chgData name="Gregor Schroeder" userId="b5dc7317-29c0-420d-a3e1-6a07614f8ec9" providerId="ADAL" clId="{045A2BD9-4324-4B3B-AE34-A1847A3B2362}" dt="2026-09-17T16:17:27.517" v="26" actId="20577"/>
+          <ac:chgData name="Gregor Schroeder" userId="b5dc7317-29c0-420d-a3e1-6a07614f8ec9" providerId="ADAL" clId="{045A2BD9-4324-4B3B-AE34-A1847A3B2362}" dt="2026-10-21T00:25:48.645" v="129" actId="1076"/>
           <ac:spMkLst>
             <pc:docMk/>
             <pc:sldMk cId="3671389095" sldId="256"/>
             <ac:spMk id="82" creationId="{CBCF8921-64B6-A577-76D1-2E9BE28715D5}"/>
           </ac:spMkLst>
         </pc:spChg>
+        <pc:cxnChg chg="add del mod">
+          <ac:chgData name="Gregor Schroeder" userId="b5dc7317-29c0-420d-a3e1-6a07614f8ec9" providerId="ADAL" clId="{045A2BD9-4324-4B3B-AE34-A1847A3B2362}" dt="2026-10-21T00:27:26.798" v="150" actId="478"/>
+          <ac:cxnSpMkLst>
+            <pc:docMk/>
+            <pc:sldMk cId="3671389095" sldId="256"/>
+            <ac:cxnSpMk id="8" creationId="{D12F5FBF-AB7F-A2A5-EADA-3DABEE59DB97}"/>
+          </ac:cxnSpMkLst>
+        </pc:cxnChg>
         <pc:cxnChg chg="mod">
-          <ac:chgData name="Gregor Schroeder" userId="b5dc7317-29c0-420d-a3e1-6a07614f8ec9" providerId="ADAL" clId="{045A2BD9-4324-4B3B-AE34-A1847A3B2362}" dt="2026-09-29T17:02:29.499" v="55" actId="14100"/>
+          <ac:chgData name="Gregor Schroeder" userId="b5dc7317-29c0-420d-a3e1-6a07614f8ec9" providerId="ADAL" clId="{045A2BD9-4324-4B3B-AE34-A1847A3B2362}" dt="2026-10-21T00:27:13.677" v="147" actId="14100"/>
           <ac:cxnSpMkLst>
             <pc:docMk/>
             <pc:sldMk cId="3671389095" sldId="256"/>
@@ -208,11 +336,43 @@
           </ac:cxnSpMkLst>
         </pc:cxnChg>
         <pc:cxnChg chg="mod">
-          <ac:chgData name="Gregor Schroeder" userId="b5dc7317-29c0-420d-a3e1-6a07614f8ec9" providerId="ADAL" clId="{045A2BD9-4324-4B3B-AE34-A1847A3B2362}" dt="2026-09-29T17:02:29.499" v="55" actId="14100"/>
+          <ac:chgData name="Gregor Schroeder" userId="b5dc7317-29c0-420d-a3e1-6a07614f8ec9" providerId="ADAL" clId="{045A2BD9-4324-4B3B-AE34-A1847A3B2362}" dt="2026-10-21T00:29:25.149" v="232" actId="14100"/>
           <ac:cxnSpMkLst>
             <pc:docMk/>
             <pc:sldMk cId="3671389095" sldId="256"/>
             <ac:cxnSpMk id="13" creationId="{08DBA490-DA57-9602-65F0-076438C61A53}"/>
+          </ac:cxnSpMkLst>
+        </pc:cxnChg>
+        <pc:cxnChg chg="add mod">
+          <ac:chgData name="Gregor Schroeder" userId="b5dc7317-29c0-420d-a3e1-6a07614f8ec9" providerId="ADAL" clId="{045A2BD9-4324-4B3B-AE34-A1847A3B2362}" dt="2026-10-21T00:30:59.864" v="244" actId="14100"/>
+          <ac:cxnSpMkLst>
+            <pc:docMk/>
+            <pc:sldMk cId="3671389095" sldId="256"/>
+            <ac:cxnSpMk id="22" creationId="{E2C4BE68-E3FB-09A1-58C7-50D702C6D975}"/>
+          </ac:cxnSpMkLst>
+        </pc:cxnChg>
+        <pc:cxnChg chg="mod">
+          <ac:chgData name="Gregor Schroeder" userId="b5dc7317-29c0-420d-a3e1-6a07614f8ec9" providerId="ADAL" clId="{045A2BD9-4324-4B3B-AE34-A1847A3B2362}" dt="2026-10-21T00:29:32.354" v="233" actId="1076"/>
+          <ac:cxnSpMkLst>
+            <pc:docMk/>
+            <pc:sldMk cId="3671389095" sldId="256"/>
+            <ac:cxnSpMk id="29" creationId="{97D5980A-9087-33A6-3FD4-679945137B34}"/>
+          </ac:cxnSpMkLst>
+        </pc:cxnChg>
+        <pc:cxnChg chg="mod">
+          <ac:chgData name="Gregor Schroeder" userId="b5dc7317-29c0-420d-a3e1-6a07614f8ec9" providerId="ADAL" clId="{045A2BD9-4324-4B3B-AE34-A1847A3B2362}" dt="2026-10-21T00:30:40.647" v="242" actId="14100"/>
+          <ac:cxnSpMkLst>
+            <pc:docMk/>
+            <pc:sldMk cId="3671389095" sldId="256"/>
+            <ac:cxnSpMk id="32" creationId="{804C74ED-DB1E-3D98-0BE4-CEE86D2A2FF1}"/>
+          </ac:cxnSpMkLst>
+        </pc:cxnChg>
+        <pc:cxnChg chg="mod">
+          <ac:chgData name="Gregor Schroeder" userId="b5dc7317-29c0-420d-a3e1-6a07614f8ec9" providerId="ADAL" clId="{045A2BD9-4324-4B3B-AE34-A1847A3B2362}" dt="2026-10-21T00:30:33.135" v="241" actId="1076"/>
+          <ac:cxnSpMkLst>
+            <pc:docMk/>
+            <pc:sldMk cId="3671389095" sldId="256"/>
+            <ac:cxnSpMk id="37" creationId="{2FA73483-7DDC-4D0B-B08F-C6E74933524E}"/>
           </ac:cxnSpMkLst>
         </pc:cxnChg>
         <pc:cxnChg chg="mod">
@@ -376,7 +536,7 @@
           <a:p>
             <a:fld id="{178E86BF-7F65-43CF-AE46-EFD7C683430B}" type="datetimeFigureOut">
               <a:rPr lang="en-US" smtClean="0"/>
-              <a:t>9/29/2026</a:t>
+              <a:t>10/20/2026</a:t>
             </a:fld>
             <a:endParaRPr lang="en-US"/>
           </a:p>
@@ -574,7 +734,7 @@
           <a:p>
             <a:fld id="{178E86BF-7F65-43CF-AE46-EFD7C683430B}" type="datetimeFigureOut">
               <a:rPr lang="en-US" smtClean="0"/>
-              <a:t>9/29/2026</a:t>
+              <a:t>10/20/2026</a:t>
             </a:fld>
             <a:endParaRPr lang="en-US"/>
           </a:p>
@@ -782,7 +942,7 @@
           <a:p>
             <a:fld id="{178E86BF-7F65-43CF-AE46-EFD7C683430B}" type="datetimeFigureOut">
               <a:rPr lang="en-US" smtClean="0"/>
-              <a:t>9/29/2026</a:t>
+              <a:t>10/20/2026</a:t>
             </a:fld>
             <a:endParaRPr lang="en-US"/>
           </a:p>
@@ -980,7 +1140,7 @@
           <a:p>
             <a:fld id="{178E86BF-7F65-43CF-AE46-EFD7C683430B}" type="datetimeFigureOut">
               <a:rPr lang="en-US" smtClean="0"/>
-              <a:t>9/29/2026</a:t>
+              <a:t>10/20/2026</a:t>
             </a:fld>
             <a:endParaRPr lang="en-US"/>
           </a:p>
@@ -1255,7 +1415,7 @@
           <a:p>
             <a:fld id="{178E86BF-7F65-43CF-AE46-EFD7C683430B}" type="datetimeFigureOut">
               <a:rPr lang="en-US" smtClean="0"/>
-              <a:t>9/29/2026</a:t>
+              <a:t>10/20/2026</a:t>
             </a:fld>
             <a:endParaRPr lang="en-US"/>
           </a:p>
@@ -1520,7 +1680,7 @@
           <a:p>
             <a:fld id="{178E86BF-7F65-43CF-AE46-EFD7C683430B}" type="datetimeFigureOut">
               <a:rPr lang="en-US" smtClean="0"/>
-              <a:t>9/29/2026</a:t>
+              <a:t>10/20/2026</a:t>
             </a:fld>
             <a:endParaRPr lang="en-US"/>
           </a:p>
@@ -1932,7 +2092,7 @@
           <a:p>
             <a:fld id="{178E86BF-7F65-43CF-AE46-EFD7C683430B}" type="datetimeFigureOut">
               <a:rPr lang="en-US" smtClean="0"/>
-              <a:t>9/29/2026</a:t>
+              <a:t>10/20/2026</a:t>
             </a:fld>
             <a:endParaRPr lang="en-US"/>
           </a:p>
@@ -2073,7 +2233,7 @@
           <a:p>
             <a:fld id="{178E86BF-7F65-43CF-AE46-EFD7C683430B}" type="datetimeFigureOut">
               <a:rPr lang="en-US" smtClean="0"/>
-              <a:t>9/29/2026</a:t>
+              <a:t>10/20/2026</a:t>
             </a:fld>
             <a:endParaRPr lang="en-US"/>
           </a:p>
@@ -2186,7 +2346,7 @@
           <a:p>
             <a:fld id="{178E86BF-7F65-43CF-AE46-EFD7C683430B}" type="datetimeFigureOut">
               <a:rPr lang="en-US" smtClean="0"/>
-              <a:t>9/29/2026</a:t>
+              <a:t>10/20/2026</a:t>
             </a:fld>
             <a:endParaRPr lang="en-US"/>
           </a:p>
@@ -2497,7 +2657,7 @@
           <a:p>
             <a:fld id="{178E86BF-7F65-43CF-AE46-EFD7C683430B}" type="datetimeFigureOut">
               <a:rPr lang="en-US" smtClean="0"/>
-              <a:t>9/29/2026</a:t>
+              <a:t>10/20/2026</a:t>
             </a:fld>
             <a:endParaRPr lang="en-US"/>
           </a:p>
@@ -2785,7 +2945,7 @@
           <a:p>
             <a:fld id="{178E86BF-7F65-43CF-AE46-EFD7C683430B}" type="datetimeFigureOut">
               <a:rPr lang="en-US" smtClean="0"/>
-              <a:t>9/29/2026</a:t>
+              <a:t>10/20/2026</a:t>
             </a:fld>
             <a:endParaRPr lang="en-US"/>
           </a:p>
@@ -3026,7 +3186,7 @@
           <a:p>
             <a:fld id="{178E86BF-7F65-43CF-AE46-EFD7C683430B}" type="datetimeFigureOut">
               <a:rPr lang="en-US" smtClean="0"/>
-              <a:t>9/29/2026</a:t>
+              <a:t>10/20/2026</a:t>
             </a:fld>
             <a:endParaRPr lang="en-US"/>
           </a:p>
@@ -3457,7 +3617,7 @@
         </p:nvSpPr>
         <p:spPr>
           <a:xfrm>
-            <a:off x="702674" y="3080421"/>
+            <a:off x="365554" y="3079716"/>
             <a:ext cx="1062892" cy="625912"/>
           </a:xfrm>
           <a:prstGeom prst="roundRect">
@@ -3513,7 +3673,7 @@
         </p:nvSpPr>
         <p:spPr>
           <a:xfrm>
-            <a:off x="1833873" y="3265923"/>
+            <a:off x="1496753" y="3265218"/>
             <a:ext cx="539530" cy="273538"/>
           </a:xfrm>
           <a:prstGeom prst="rightArrow">
@@ -3665,8 +3825,8 @@
         </p:nvCxnSpPr>
         <p:spPr>
           <a:xfrm flipH="1">
-            <a:off x="3623603" y="1858984"/>
-            <a:ext cx="682115" cy="625912"/>
+            <a:off x="3465269" y="1858984"/>
+            <a:ext cx="840449" cy="350265"/>
           </a:xfrm>
           <a:prstGeom prst="straightConnector1">
             <a:avLst/>
@@ -3708,7 +3868,7 @@
         <p:spPr>
           <a:xfrm>
             <a:off x="4305718" y="1858984"/>
-            <a:ext cx="763732" cy="606811"/>
+            <a:ext cx="738480" cy="391017"/>
           </a:xfrm>
           <a:prstGeom prst="straightConnector1">
             <a:avLst/>
@@ -3746,7 +3906,7 @@
         </p:nvSpPr>
         <p:spPr>
           <a:xfrm>
-            <a:off x="2597695" y="2571503"/>
+            <a:off x="2637306" y="2250001"/>
             <a:ext cx="1399592" cy="555531"/>
           </a:xfrm>
           <a:prstGeom prst="flowChartAlternateProcess">
@@ -3793,7 +3953,7 @@
         </p:nvSpPr>
         <p:spPr>
           <a:xfrm>
-            <a:off x="2540892" y="2622424"/>
+            <a:off x="2580503" y="2300922"/>
             <a:ext cx="1473480" cy="461665"/>
           </a:xfrm>
           <a:prstGeom prst="rect">
@@ -3836,7 +3996,7 @@
         </p:nvSpPr>
         <p:spPr>
           <a:xfrm>
-            <a:off x="4555731" y="2567835"/>
+            <a:off x="4580521" y="2289387"/>
             <a:ext cx="1399592" cy="555531"/>
           </a:xfrm>
           <a:prstGeom prst="flowChartAlternateProcess">
@@ -3883,7 +4043,7 @@
         </p:nvSpPr>
         <p:spPr>
           <a:xfrm>
-            <a:off x="4595749" y="2618756"/>
+            <a:off x="4620539" y="2340308"/>
             <a:ext cx="1279839" cy="461665"/>
           </a:xfrm>
           <a:prstGeom prst="rect">
@@ -3928,7 +4088,7 @@
         </p:nvCxnSpPr>
         <p:spPr>
           <a:xfrm>
-            <a:off x="5255527" y="3123366"/>
+            <a:off x="5280317" y="2844918"/>
             <a:ext cx="0" cy="377927"/>
           </a:xfrm>
           <a:prstGeom prst="straightConnector1">
@@ -3967,7 +4127,7 @@
         </p:nvSpPr>
         <p:spPr>
           <a:xfrm>
-            <a:off x="4724081" y="3544237"/>
+            <a:off x="4748871" y="3265789"/>
             <a:ext cx="1062892" cy="500503"/>
           </a:xfrm>
           <a:prstGeom prst="rect">
@@ -4018,7 +4178,7 @@
         </p:nvSpPr>
         <p:spPr>
           <a:xfrm>
-            <a:off x="4645199" y="3563655"/>
+            <a:off x="4669989" y="3285207"/>
             <a:ext cx="1220655" cy="461665"/>
           </a:xfrm>
           <a:prstGeom prst="rect">
@@ -4064,13 +4224,15 @@
               </a:ext>
             </a:extLst>
           </p:cNvPr>
-          <p:cNvCxnSpPr/>
+          <p:cNvCxnSpPr>
+            <a:cxnSpLocks/>
+          </p:cNvCxnSpPr>
           <p:nvPr/>
         </p:nvCxnSpPr>
         <p:spPr>
-          <a:xfrm>
-            <a:off x="3227434" y="3133694"/>
-            <a:ext cx="0" cy="377927"/>
+          <a:xfrm flipH="1">
+            <a:off x="2868253" y="2809980"/>
+            <a:ext cx="435956" cy="393031"/>
           </a:xfrm>
           <a:prstGeom prst="straightConnector1">
             <a:avLst/>
@@ -4108,7 +4270,7 @@
         </p:nvSpPr>
         <p:spPr>
           <a:xfrm>
-            <a:off x="2628956" y="3535941"/>
+            <a:off x="2210231" y="3309681"/>
             <a:ext cx="1220654" cy="626038"/>
           </a:xfrm>
           <a:prstGeom prst="flowChartAlternateProcess">
@@ -4155,7 +4317,7 @@
         </p:nvSpPr>
         <p:spPr>
           <a:xfrm>
-            <a:off x="2640036" y="3515648"/>
+            <a:off x="2221311" y="3289388"/>
             <a:ext cx="1209573" cy="646331"/>
           </a:xfrm>
           <a:prstGeom prst="rect">
@@ -4200,13 +4362,15 @@
               </a:ext>
             </a:extLst>
           </p:cNvPr>
-          <p:cNvCxnSpPr/>
+          <p:cNvCxnSpPr>
+            <a:cxnSpLocks/>
+          </p:cNvCxnSpPr>
           <p:nvPr/>
         </p:nvCxnSpPr>
         <p:spPr>
           <a:xfrm>
-            <a:off x="3229849" y="4161979"/>
-            <a:ext cx="0" cy="377927"/>
+            <a:off x="2824434" y="3935719"/>
+            <a:ext cx="0" cy="317634"/>
           </a:xfrm>
           <a:prstGeom prst="straightConnector1">
             <a:avLst/>
@@ -4244,7 +4408,7 @@
         </p:nvSpPr>
         <p:spPr>
           <a:xfrm>
-            <a:off x="2731974" y="4570886"/>
+            <a:off x="2284482" y="4292044"/>
             <a:ext cx="1062892" cy="500503"/>
           </a:xfrm>
           <a:prstGeom prst="rect">
@@ -4295,7 +4459,7 @@
         </p:nvSpPr>
         <p:spPr>
           <a:xfrm>
-            <a:off x="2671545" y="4606099"/>
+            <a:off x="2224053" y="4327257"/>
             <a:ext cx="1156792" cy="461665"/>
           </a:xfrm>
           <a:prstGeom prst="rect">
@@ -4350,8 +4514,8 @@
         </p:nvSpPr>
         <p:spPr>
           <a:xfrm>
-            <a:off x="2438400" y="1229529"/>
-            <a:ext cx="3657600" cy="4165600"/>
+            <a:off x="2102247" y="1229529"/>
+            <a:ext cx="4123547" cy="4165600"/>
           </a:xfrm>
           <a:prstGeom prst="flowChartAlternateProcess">
             <a:avLst/>
@@ -4397,8 +4561,8 @@
         </p:nvSpPr>
         <p:spPr>
           <a:xfrm>
-            <a:off x="3127939" y="948664"/>
-            <a:ext cx="2335576" cy="307777"/>
+            <a:off x="2610400" y="941534"/>
+            <a:ext cx="3115405" cy="307777"/>
           </a:xfrm>
           <a:prstGeom prst="rect">
             <a:avLst/>
@@ -4414,7 +4578,7 @@
             <a:pPr algn="ctr"/>
             <a:r>
               <a:rPr lang="en-US" sz="1400" dirty="0"/>
-              <a:t>Population and Households</a:t>
+              <a:t>Population, Households, and Housing</a:t>
             </a:r>
           </a:p>
         </p:txBody>
@@ -5431,7 +5595,7 @@
         </p:nvSpPr>
         <p:spPr>
           <a:xfrm>
-            <a:off x="415883" y="2562889"/>
+            <a:off x="78763" y="2562184"/>
             <a:ext cx="1661609" cy="523220"/>
           </a:xfrm>
           <a:prstGeom prst="rect">
@@ -5456,6 +5620,164 @@
             <a:r>
               <a:rPr lang="en-US" sz="1400" dirty="0"/>
               <a:t>SANDAG Estimates</a:t>
+            </a:r>
+          </a:p>
+        </p:txBody>
+      </p:sp>
+      <p:cxnSp>
+        <p:nvCxnSpPr>
+          <p:cNvPr id="22" name="Straight Arrow Connector 21">
+            <a:extLst>
+              <a:ext uri="{FF2B5EF4-FFF2-40B4-BE49-F238E27FC236}">
+                <a16:creationId xmlns:a16="http://schemas.microsoft.com/office/drawing/2014/main" id="{E2C4BE68-E3FB-09A1-58C7-50D702C6D975}"/>
+              </a:ext>
+            </a:extLst>
+          </p:cNvPr>
+          <p:cNvCxnSpPr>
+            <a:cxnSpLocks/>
+          </p:cNvCxnSpPr>
+          <p:nvPr/>
+        </p:nvCxnSpPr>
+        <p:spPr>
+          <a:xfrm>
+            <a:off x="3430382" y="2805532"/>
+            <a:ext cx="754876" cy="1359972"/>
+          </a:xfrm>
+          <a:prstGeom prst="straightConnector1">
+            <a:avLst/>
+          </a:prstGeom>
+          <a:ln>
+            <a:tailEnd type="triangle"/>
+          </a:ln>
+        </p:spPr>
+        <p:style>
+          <a:lnRef idx="2">
+            <a:schemeClr val="dk1"/>
+          </a:lnRef>
+          <a:fillRef idx="0">
+            <a:schemeClr val="dk1"/>
+          </a:fillRef>
+          <a:effectRef idx="1">
+            <a:schemeClr val="dk1"/>
+          </a:effectRef>
+          <a:fontRef idx="minor">
+            <a:schemeClr val="tx1"/>
+          </a:fontRef>
+        </p:style>
+      </p:cxnSp>
+      <p:sp>
+        <p:nvSpPr>
+          <p:cNvPr id="27" name="Rectangle 26">
+            <a:extLst>
+              <a:ext uri="{FF2B5EF4-FFF2-40B4-BE49-F238E27FC236}">
+                <a16:creationId xmlns:a16="http://schemas.microsoft.com/office/drawing/2014/main" id="{36ED4FAD-EDFF-2D9B-ACEA-4318FAFBA454}"/>
+              </a:ext>
+            </a:extLst>
+          </p:cNvPr>
+          <p:cNvSpPr/>
+          <p:nvPr/>
+        </p:nvSpPr>
+        <p:spPr>
+          <a:xfrm>
+            <a:off x="3557702" y="4258845"/>
+            <a:ext cx="1372107" cy="627975"/>
+          </a:xfrm>
+          <a:prstGeom prst="rect">
+            <a:avLst/>
+          </a:prstGeom>
+          <a:noFill/>
+        </p:spPr>
+        <p:style>
+          <a:lnRef idx="2">
+            <a:schemeClr val="accent1">
+              <a:shade val="15000"/>
+            </a:schemeClr>
+          </a:lnRef>
+          <a:fillRef idx="1">
+            <a:schemeClr val="accent1"/>
+          </a:fillRef>
+          <a:effectRef idx="0">
+            <a:schemeClr val="accent1"/>
+          </a:effectRef>
+          <a:fontRef idx="minor">
+            <a:schemeClr val="lt1"/>
+          </a:fontRef>
+        </p:style>
+        <p:txBody>
+          <a:bodyPr rtlCol="0" anchor="ctr"/>
+          <a:lstStyle/>
+          <a:p>
+            <a:pPr algn="ctr"/>
+            <a:endParaRPr lang="en-US">
+              <a:highlight>
+                <a:srgbClr val="FFFF00"/>
+              </a:highlight>
+            </a:endParaRPr>
+          </a:p>
+        </p:txBody>
+      </p:sp>
+      <p:sp>
+        <p:nvSpPr>
+          <p:cNvPr id="35" name="TextBox 34">
+            <a:extLst>
+              <a:ext uri="{FF2B5EF4-FFF2-40B4-BE49-F238E27FC236}">
+                <a16:creationId xmlns:a16="http://schemas.microsoft.com/office/drawing/2014/main" id="{BDAEA6C6-03B8-D62B-ACC1-ABA1FEF7D8CA}"/>
+              </a:ext>
+            </a:extLst>
+          </p:cNvPr>
+          <p:cNvSpPr txBox="1"/>
+          <p:nvPr/>
+        </p:nvSpPr>
+        <p:spPr>
+          <a:xfrm>
+            <a:off x="3524231" y="4247835"/>
+            <a:ext cx="1405578" cy="646331"/>
+          </a:xfrm>
+          <a:prstGeom prst="rect">
+            <a:avLst/>
+          </a:prstGeom>
+          <a:noFill/>
+        </p:spPr>
+        <p:txBody>
+          <a:bodyPr wrap="none" rtlCol="0">
+            <a:spAutoFit/>
+          </a:bodyPr>
+          <a:lstStyle/>
+          <a:p>
+            <a:pPr algn="ctr"/>
+            <a:r>
+              <a:rPr lang="en-US" sz="1200" dirty="0">
+                <a:highlight>
+                  <a:srgbClr val="FFFF00"/>
+                </a:highlight>
+              </a:rPr>
+              <a:t>Households</a:t>
+            </a:r>
+            <a:br>
+              <a:rPr lang="en-US" sz="1200" dirty="0">
+                <a:highlight>
+                  <a:srgbClr val="FFFF00"/>
+                </a:highlight>
+              </a:rPr>
+            </a:br>
+            <a:r>
+              <a:rPr lang="en-US" sz="1200" dirty="0">
+                <a:highlight>
+                  <a:srgbClr val="FFFF00"/>
+                </a:highlight>
+              </a:rPr>
+              <a:t>and Housing Units</a:t>
+            </a:r>
+          </a:p>
+          <a:p>
+            <a:pPr algn="ctr"/>
+            <a:r>
+              <a:rPr lang="en-US" sz="1200" dirty="0">
+                <a:highlight>
+                  <a:srgbClr val="FFFF00"/>
+                </a:highlight>
+              </a:rPr>
+              <a:t>by Structure Type</a:t>
             </a:r>
           </a:p>
         </p:txBody>

</xml_diff>